<commit_message>
Demo Deck and video
</commit_message>
<xml_diff>
--- a/docs/AgeBand_AMD_Pitch.pptx
+++ b/docs/AgeBand_AMD_Pitch.pptx
@@ -1604,7 +1604,7 @@
           <a:p>
             <a:fld id="{5BCAD085-E8A6-8845-BD4E-CB4CCA059FC4}" type="datetimeFigureOut">
               <a:rPr lang="en-US" smtClean="0"/>
-              <a:t>7/7/2026</a:t>
+              <a:t>7/10/2026</a:t>
             </a:fld>
             <a:endParaRPr lang="en-US"/>
           </a:p>
@@ -1772,7 +1772,7 @@
           <a:p>
             <a:fld id="{5BCAD085-E8A6-8845-BD4E-CB4CCA059FC4}" type="datetimeFigureOut">
               <a:rPr lang="en-US" smtClean="0"/>
-              <a:t>7/7/2026</a:t>
+              <a:t>7/10/2026</a:t>
             </a:fld>
             <a:endParaRPr lang="en-US"/>
           </a:p>
@@ -1950,7 +1950,7 @@
           <a:p>
             <a:fld id="{5BCAD085-E8A6-8845-BD4E-CB4CCA059FC4}" type="datetimeFigureOut">
               <a:rPr lang="en-US" smtClean="0"/>
-              <a:t>7/7/2026</a:t>
+              <a:t>7/10/2026</a:t>
             </a:fld>
             <a:endParaRPr lang="en-US"/>
           </a:p>
@@ -2118,7 +2118,7 @@
           <a:p>
             <a:fld id="{5BCAD085-E8A6-8845-BD4E-CB4CCA059FC4}" type="datetimeFigureOut">
               <a:rPr lang="en-US" smtClean="0"/>
-              <a:t>7/7/2026</a:t>
+              <a:t>7/10/2026</a:t>
             </a:fld>
             <a:endParaRPr lang="en-US"/>
           </a:p>
@@ -2363,7 +2363,7 @@
           <a:p>
             <a:fld id="{5BCAD085-E8A6-8845-BD4E-CB4CCA059FC4}" type="datetimeFigureOut">
               <a:rPr lang="en-US" smtClean="0"/>
-              <a:t>7/7/2026</a:t>
+              <a:t>7/10/2026</a:t>
             </a:fld>
             <a:endParaRPr lang="en-US"/>
           </a:p>
@@ -2648,7 +2648,7 @@
           <a:p>
             <a:fld id="{5BCAD085-E8A6-8845-BD4E-CB4CCA059FC4}" type="datetimeFigureOut">
               <a:rPr lang="en-US" smtClean="0"/>
-              <a:t>7/7/2026</a:t>
+              <a:t>7/10/2026</a:t>
             </a:fld>
             <a:endParaRPr lang="en-US"/>
           </a:p>
@@ -3067,7 +3067,7 @@
           <a:p>
             <a:fld id="{5BCAD085-E8A6-8845-BD4E-CB4CCA059FC4}" type="datetimeFigureOut">
               <a:rPr lang="en-US" smtClean="0"/>
-              <a:t>7/7/2026</a:t>
+              <a:t>7/10/2026</a:t>
             </a:fld>
             <a:endParaRPr lang="en-US"/>
           </a:p>
@@ -3184,7 +3184,7 @@
           <a:p>
             <a:fld id="{5BCAD085-E8A6-8845-BD4E-CB4CCA059FC4}" type="datetimeFigureOut">
               <a:rPr lang="en-US" smtClean="0"/>
-              <a:t>7/7/2026</a:t>
+              <a:t>7/10/2026</a:t>
             </a:fld>
             <a:endParaRPr lang="en-US"/>
           </a:p>
@@ -3279,7 +3279,7 @@
           <a:p>
             <a:fld id="{5BCAD085-E8A6-8845-BD4E-CB4CCA059FC4}" type="datetimeFigureOut">
               <a:rPr lang="en-US" smtClean="0"/>
-              <a:t>7/7/2026</a:t>
+              <a:t>7/10/2026</a:t>
             </a:fld>
             <a:endParaRPr lang="en-US"/>
           </a:p>
@@ -3554,7 +3554,7 @@
           <a:p>
             <a:fld id="{5BCAD085-E8A6-8845-BD4E-CB4CCA059FC4}" type="datetimeFigureOut">
               <a:rPr lang="en-US" smtClean="0"/>
-              <a:t>7/7/2026</a:t>
+              <a:t>7/10/2026</a:t>
             </a:fld>
             <a:endParaRPr lang="en-US"/>
           </a:p>
@@ -3806,7 +3806,7 @@
           <a:p>
             <a:fld id="{5BCAD085-E8A6-8845-BD4E-CB4CCA059FC4}" type="datetimeFigureOut">
               <a:rPr lang="en-US" smtClean="0"/>
-              <a:t>7/7/2026</a:t>
+              <a:t>7/10/2026</a:t>
             </a:fld>
             <a:endParaRPr lang="en-US"/>
           </a:p>
@@ -4017,7 +4017,7 @@
           <a:p>
             <a:fld id="{5BCAD085-E8A6-8845-BD4E-CB4CCA059FC4}" type="datetimeFigureOut">
               <a:rPr lang="en-US" smtClean="0"/>
-              <a:t>7/7/2026</a:t>
+              <a:t>7/10/2026</a:t>
             </a:fld>
             <a:endParaRPr lang="en-US"/>
           </a:p>
@@ -4918,7 +4918,7 @@
         <p:spPr>
           <a:xfrm>
             <a:off x="8778240" y="1956816"/>
-            <a:ext cx="1920240" cy="384048"/>
+            <a:ext cx="1920240" cy="246221"/>
           </a:xfrm>
           <a:prstGeom prst="rect">
             <a:avLst/>
@@ -4933,9 +4933,9 @@
           <a:p>
             <a:pPr algn="r"/>
             <a:r>
-              <a:rPr lang="en-US" sz="1000" b="0" i="0" noProof="1">
-                <a:solidFill>
-                  <a:srgbClr val="FCA5A5"/>
+              <a:rPr lang="en-US" sz="1600" b="1" i="0" noProof="1">
+                <a:solidFill>
+                  <a:schemeClr val="bg1"/>
                 </a:solidFill>
                 <a:latin typeface="Calibri"/>
               </a:rPr>
@@ -4953,7 +4953,7 @@
         <p:spPr>
           <a:xfrm>
             <a:off x="8778240" y="3054096"/>
-            <a:ext cx="1920240" cy="384048"/>
+            <a:ext cx="1920240" cy="246221"/>
           </a:xfrm>
           <a:prstGeom prst="rect">
             <a:avLst/>
@@ -4968,9 +4968,9 @@
           <a:p>
             <a:pPr algn="r"/>
             <a:r>
-              <a:rPr lang="en-US" sz="1000" b="0" i="0" noProof="1">
-                <a:solidFill>
-                  <a:srgbClr val="FCD34D"/>
+              <a:rPr lang="en-US" sz="1600" b="1" i="0" noProof="1">
+                <a:solidFill>
+                  <a:schemeClr val="bg1"/>
                 </a:solidFill>
                 <a:latin typeface="Calibri"/>
               </a:rPr>
@@ -4988,7 +4988,7 @@
         <p:spPr>
           <a:xfrm>
             <a:off x="8778240" y="4151376"/>
-            <a:ext cx="1920240" cy="384048"/>
+            <a:ext cx="1920240" cy="246221"/>
           </a:xfrm>
           <a:prstGeom prst="rect">
             <a:avLst/>
@@ -5003,9 +5003,9 @@
           <a:p>
             <a:pPr algn="r"/>
             <a:r>
-              <a:rPr lang="en-US" sz="1000" b="0" i="0" noProof="1">
-                <a:solidFill>
-                  <a:srgbClr val="6EE7B7"/>
+              <a:rPr lang="en-US" sz="1600" b="1" i="0" noProof="1">
+                <a:solidFill>
+                  <a:schemeClr val="bg1"/>
                 </a:solidFill>
                 <a:latin typeface="Calibri"/>
               </a:rPr>

</xml_diff>